<commit_message>
Update SCLAS PPTX portfolio text to align with latest solver integration workflow
</commit_message>
<xml_diff>
--- a/portfolio/SCLAS_Portfolio_Overview_KR.pptx
+++ b/portfolio/SCLAS_Portfolio_Overview_KR.pptx
@@ -1549,6 +1549,10 @@
             <a:prstDash val="solid"/>
           </a:ln>
         </p:spPr>
+        <p:txBody xmlns:a="http://schemas.openxmlformats.org/drawingml/2006/main">
+          <a:bodyPr/>
+          <a:p/>
+        </p:txBody>
       </p:sp>
       <p:sp>
         <p:nvSpPr>
@@ -1582,6 +1586,10 @@
             <a:prstDash val="solid"/>
           </a:ln>
         </p:spPr>
+        <p:txBody xmlns:a="http://schemas.openxmlformats.org/drawingml/2006/main">
+          <a:bodyPr/>
+          <a:p/>
+        </p:txBody>
       </p:sp>
       <p:sp>
         <p:nvSpPr>
@@ -1728,7 +1736,7 @@
                 <a:ea typeface="Malgun Gothic"/>
                 <a:cs typeface="Malgun Gothic"/>
               </a:rPr>
-              <a:t>Abaqus를 숨겨진 해석 엔진으로 연결하는 AI-assisted engineering workflow</a:t>
+              <a:t>Abaqus Standard 해석 및 ODB 데이터 추출까지 원클릭으로 통합한 자동화 플랫폼</a:t>
             </a:r>
           </a:p>
         </p:txBody>
@@ -1765,6 +1773,10 @@
             <a:prstDash val="solid"/>
           </a:ln>
         </p:spPr>
+        <p:txBody xmlns:a="http://schemas.openxmlformats.org/drawingml/2006/main">
+          <a:bodyPr/>
+          <a:p/>
+        </p:txBody>
       </p:sp>
       <p:sp>
         <p:nvSpPr>
@@ -1911,6 +1923,10 @@
             <a:prstDash val="solid"/>
           </a:ln>
         </p:spPr>
+        <p:txBody xmlns:a="http://schemas.openxmlformats.org/drawingml/2006/main">
+          <a:bodyPr/>
+          <a:p/>
+        </p:txBody>
       </p:sp>
       <p:sp>
         <p:nvSpPr>
@@ -2116,6 +2132,10 @@
             <a:prstDash val="solid"/>
           </a:ln>
         </p:spPr>
+        <p:txBody xmlns:a="http://schemas.openxmlformats.org/drawingml/2006/main">
+          <a:bodyPr/>
+          <a:p/>
+        </p:txBody>
       </p:sp>
       <p:sp>
         <p:nvSpPr>
@@ -2149,6 +2169,10 @@
             <a:prstDash val="solid"/>
           </a:ln>
         </p:spPr>
+        <p:txBody xmlns:a="http://schemas.openxmlformats.org/drawingml/2006/main">
+          <a:bodyPr/>
+          <a:p/>
+        </p:txBody>
       </p:sp>
       <p:sp>
         <p:nvSpPr>
@@ -2382,6 +2406,10 @@
             <a:prstDash val="solid"/>
           </a:ln>
         </p:spPr>
+        <p:txBody xmlns:a="http://schemas.openxmlformats.org/drawingml/2006/main">
+          <a:bodyPr/>
+          <a:p/>
+        </p:txBody>
       </p:sp>
       <p:sp>
         <p:nvSpPr>
@@ -2515,6 +2543,10 @@
             <a:prstDash val="solid"/>
           </a:ln>
         </p:spPr>
+        <p:txBody xmlns:a="http://schemas.openxmlformats.org/drawingml/2006/main">
+          <a:bodyPr/>
+          <a:p/>
+        </p:txBody>
       </p:sp>
       <p:sp>
         <p:nvSpPr>
@@ -2611,7 +2643,7 @@
                 <a:ea typeface="Malgun Gothic"/>
                 <a:cs typeface="Malgun Gothic"/>
               </a:rPr>
-              <a:t>Abaqus 모델 생성과 실행 절차가 수동화되기 쉬움</a:t>
+              <a:t>GUI-Abaqus Standard 해석 및 ODB 추출 연동으로 수동 절차 완전 자동화 완료</a:t>
             </a:r>
           </a:p>
         </p:txBody>
@@ -2648,6 +2680,10 @@
             <a:prstDash val="solid"/>
           </a:ln>
         </p:spPr>
+        <p:txBody xmlns:a="http://schemas.openxmlformats.org/drawingml/2006/main">
+          <a:bodyPr/>
+          <a:p/>
+        </p:txBody>
       </p:sp>
       <p:sp>
         <p:nvSpPr>
@@ -2781,6 +2817,10 @@
             <a:prstDash val="solid"/>
           </a:ln>
         </p:spPr>
+        <p:txBody xmlns:a="http://schemas.openxmlformats.org/drawingml/2006/main">
+          <a:bodyPr/>
+          <a:p/>
+        </p:txBody>
       </p:sp>
       <p:sp>
         <p:nvSpPr>
@@ -2914,6 +2954,10 @@
             <a:prstDash val="solid"/>
           </a:ln>
         </p:spPr>
+        <p:txBody xmlns:a="http://schemas.openxmlformats.org/drawingml/2006/main">
+          <a:bodyPr/>
+          <a:p/>
+        </p:txBody>
       </p:sp>
       <p:sp>
         <p:nvSpPr>
@@ -2947,6 +2991,10 @@
             <a:prstDash val="solid"/>
           </a:ln>
         </p:spPr>
+        <p:txBody xmlns:a="http://schemas.openxmlformats.org/drawingml/2006/main">
+          <a:bodyPr/>
+          <a:p/>
+        </p:txBody>
       </p:sp>
       <p:sp>
         <p:nvSpPr>
@@ -3043,7 +3091,7 @@
                 <a:ea typeface="Malgun Gothic"/>
                 <a:cs typeface="Malgun Gothic"/>
               </a:rPr>
-              <a:t>GUI만 조작해도 입력 생성, Abaqus 실행, 결과 수집, 요약 표시, 팀 전달 문서까지 이어지는 하나의 분석 제품으로 만들어야 한다.</a:t>
+              <a:t>GUI 원클릭으로 입력 생성, Abaqus Standard 해석, ODB 결과 자동 수집 및 플롯 표출까지 원스톱으로 작동하는 통합 분석 제품 구현 완료</a:t>
             </a:r>
           </a:p>
         </p:txBody>
@@ -3102,6 +3150,10 @@
             <a:prstDash val="solid"/>
           </a:ln>
         </p:spPr>
+        <p:txBody xmlns:a="http://schemas.openxmlformats.org/drawingml/2006/main">
+          <a:bodyPr/>
+          <a:p/>
+        </p:txBody>
       </p:sp>
       <p:sp>
         <p:nvSpPr>
@@ -3135,6 +3187,10 @@
             <a:prstDash val="solid"/>
           </a:ln>
         </p:spPr>
+        <p:txBody xmlns:a="http://schemas.openxmlformats.org/drawingml/2006/main">
+          <a:bodyPr/>
+          <a:p/>
+        </p:txBody>
       </p:sp>
       <p:sp>
         <p:nvSpPr>
@@ -3368,6 +3424,10 @@
             <a:prstDash val="solid"/>
           </a:ln>
         </p:spPr>
+        <p:txBody xmlns:a="http://schemas.openxmlformats.org/drawingml/2006/main">
+          <a:bodyPr/>
+          <a:p/>
+        </p:txBody>
       </p:sp>
       <p:sp>
         <p:nvSpPr>
@@ -3514,6 +3574,10 @@
             <a:prstDash val="solid"/>
           </a:ln>
         </p:spPr>
+        <p:txBody xmlns:a="http://schemas.openxmlformats.org/drawingml/2006/main">
+          <a:bodyPr/>
+          <a:p/>
+        </p:txBody>
       </p:sp>
       <p:sp>
         <p:nvSpPr>
@@ -3547,6 +3611,10 @@
             <a:prstDash val="solid"/>
           </a:ln>
         </p:spPr>
+        <p:txBody xmlns:a="http://schemas.openxmlformats.org/drawingml/2006/main">
+          <a:bodyPr/>
+          <a:p/>
+        </p:txBody>
       </p:sp>
       <p:sp>
         <p:nvSpPr>
@@ -3580,6 +3648,10 @@
             <a:prstDash val="solid"/>
           </a:ln>
         </p:spPr>
+        <p:txBody xmlns:a="http://schemas.openxmlformats.org/drawingml/2006/main">
+          <a:bodyPr/>
+          <a:p/>
+        </p:txBody>
       </p:sp>
       <p:sp>
         <p:nvSpPr>
@@ -3726,6 +3798,10 @@
             <a:prstDash val="solid"/>
           </a:ln>
         </p:spPr>
+        <p:txBody xmlns:a="http://schemas.openxmlformats.org/drawingml/2006/main">
+          <a:bodyPr/>
+          <a:p/>
+        </p:txBody>
       </p:sp>
       <p:sp>
         <p:nvSpPr>
@@ -3759,6 +3835,10 @@
             <a:prstDash val="solid"/>
           </a:ln>
         </p:spPr>
+        <p:txBody xmlns:a="http://schemas.openxmlformats.org/drawingml/2006/main">
+          <a:bodyPr/>
+          <a:p/>
+        </p:txBody>
       </p:sp>
       <p:sp>
         <p:nvSpPr>
@@ -3792,6 +3872,10 @@
             <a:prstDash val="solid"/>
           </a:ln>
         </p:spPr>
+        <p:txBody xmlns:a="http://schemas.openxmlformats.org/drawingml/2006/main">
+          <a:bodyPr/>
+          <a:p/>
+        </p:txBody>
       </p:sp>
       <p:sp>
         <p:nvSpPr>
@@ -3838,7 +3922,7 @@
                 <a:ea typeface="Malgun Gothic"/>
                 <a:cs typeface="Malgun Gothic"/>
               </a:rPr>
-              <a:t>3. Abaqus 실행</a:t>
+              <a:t>3. Abaqus Standard 실행</a:t>
             </a:r>
           </a:p>
         </p:txBody>
@@ -3938,6 +4022,10 @@
             <a:prstDash val="solid"/>
           </a:ln>
         </p:spPr>
+        <p:txBody xmlns:a="http://schemas.openxmlformats.org/drawingml/2006/main">
+          <a:bodyPr/>
+          <a:p/>
+        </p:txBody>
       </p:sp>
       <p:sp>
         <p:nvSpPr>
@@ -3971,6 +4059,10 @@
             <a:prstDash val="solid"/>
           </a:ln>
         </p:spPr>
+        <p:txBody xmlns:a="http://schemas.openxmlformats.org/drawingml/2006/main">
+          <a:bodyPr/>
+          <a:p/>
+        </p:txBody>
       </p:sp>
       <p:sp>
         <p:nvSpPr>
@@ -4004,6 +4096,10 @@
             <a:prstDash val="solid"/>
           </a:ln>
         </p:spPr>
+        <p:txBody xmlns:a="http://schemas.openxmlformats.org/drawingml/2006/main">
+          <a:bodyPr/>
+          <a:p/>
+        </p:txBody>
       </p:sp>
       <p:sp>
         <p:nvSpPr>
@@ -4050,7 +4146,7 @@
                 <a:ea typeface="Malgun Gothic"/>
                 <a:cs typeface="Malgun Gothic"/>
               </a:rPr>
-              <a:t>4. 결과 계약</a:t>
+              <a:t>4. ODB 결과 자동 추출</a:t>
             </a:r>
           </a:p>
         </p:txBody>
@@ -4150,6 +4246,10 @@
             <a:prstDash val="solid"/>
           </a:ln>
         </p:spPr>
+        <p:txBody xmlns:a="http://schemas.openxmlformats.org/drawingml/2006/main">
+          <a:bodyPr/>
+          <a:p/>
+        </p:txBody>
       </p:sp>
       <p:sp>
         <p:nvSpPr>
@@ -4183,6 +4283,10 @@
             <a:prstDash val="solid"/>
           </a:ln>
         </p:spPr>
+        <p:txBody xmlns:a="http://schemas.openxmlformats.org/drawingml/2006/main">
+          <a:bodyPr/>
+          <a:p/>
+        </p:txBody>
       </p:sp>
       <p:sp>
         <p:nvSpPr>
@@ -4216,6 +4320,10 @@
             <a:prstDash val="solid"/>
           </a:ln>
         </p:spPr>
+        <p:txBody xmlns:a="http://schemas.openxmlformats.org/drawingml/2006/main">
+          <a:bodyPr/>
+          <a:p/>
+        </p:txBody>
       </p:sp>
       <p:sp>
         <p:nvSpPr>
@@ -4362,6 +4470,10 @@
             <a:prstDash val="solid"/>
           </a:ln>
         </p:spPr>
+        <p:txBody xmlns:a="http://schemas.openxmlformats.org/drawingml/2006/main">
+          <a:bodyPr/>
+          <a:p/>
+        </p:txBody>
       </p:sp>
       <p:sp>
         <p:nvSpPr>
@@ -4408,7 +4520,7 @@
                 <a:ea typeface="Malgun Gothic"/>
                 <a:cs typeface="Malgun Gothic"/>
               </a:rPr>
-              <a:t>설계 의도</a:t>
+              <a:t>시스템 아키텍처</a:t>
             </a:r>
           </a:p>
         </p:txBody>
@@ -4458,7 +4570,7 @@
                 <a:ea typeface="Malgun Gothic"/>
                 <a:cs typeface="Malgun Gothic"/>
               </a:rPr>
-              <a:t>Abaqus가 없어도 GUI와 데이터 계약은 검증 가능하게 만들고, Abaqus가 붙으면 같은 인터페이스로 실제 해석 결과를 표시한다.</a:t>
+              <a:t>Abaqus 로컬/원격 구동 및 ODB 파이프라인 완벽 연동으로 모멘트-곡률 선도(Hysteresis Loop) 실데이터 실시간 플로팅 성공</a:t>
             </a:r>
           </a:p>
         </p:txBody>
@@ -4517,6 +4629,10 @@
             <a:prstDash val="solid"/>
           </a:ln>
         </p:spPr>
+        <p:txBody xmlns:a="http://schemas.openxmlformats.org/drawingml/2006/main">
+          <a:bodyPr/>
+          <a:p/>
+        </p:txBody>
       </p:sp>
       <p:sp>
         <p:nvSpPr>
@@ -4550,6 +4666,10 @@
             <a:prstDash val="solid"/>
           </a:ln>
         </p:spPr>
+        <p:txBody xmlns:a="http://schemas.openxmlformats.org/drawingml/2006/main">
+          <a:bodyPr/>
+          <a:p/>
+        </p:txBody>
       </p:sp>
       <p:sp>
         <p:nvSpPr>
@@ -4783,6 +4903,10 @@
             <a:prstDash val="solid"/>
           </a:ln>
         </p:spPr>
+        <p:txBody xmlns:a="http://schemas.openxmlformats.org/drawingml/2006/main">
+          <a:bodyPr/>
+          <a:p/>
+        </p:txBody>
       </p:sp>
       <p:sp>
         <p:nvSpPr>
@@ -4816,6 +4940,10 @@
             <a:prstDash val="solid"/>
           </a:ln>
         </p:spPr>
+        <p:txBody xmlns:a="http://schemas.openxmlformats.org/drawingml/2006/main">
+          <a:bodyPr/>
+          <a:p/>
+        </p:txBody>
       </p:sp>
       <p:sp>
         <p:nvSpPr>
@@ -4975,6 +5103,10 @@
             <a:prstDash val="solid"/>
           </a:ln>
         </p:spPr>
+        <p:txBody xmlns:a="http://schemas.openxmlformats.org/drawingml/2006/main">
+          <a:bodyPr/>
+          <a:p/>
+        </p:txBody>
       </p:sp>
       <p:sp>
         <p:nvSpPr>
@@ -5008,6 +5140,10 @@
             <a:prstDash val="solid"/>
           </a:ln>
         </p:spPr>
+        <p:txBody xmlns:a="http://schemas.openxmlformats.org/drawingml/2006/main">
+          <a:bodyPr/>
+          <a:p/>
+        </p:txBody>
       </p:sp>
       <p:sp>
         <p:nvSpPr>
@@ -5167,6 +5303,10 @@
             <a:prstDash val="solid"/>
           </a:ln>
         </p:spPr>
+        <p:txBody xmlns:a="http://schemas.openxmlformats.org/drawingml/2006/main">
+          <a:bodyPr/>
+          <a:p/>
+        </p:txBody>
       </p:sp>
       <p:sp>
         <p:nvSpPr>
@@ -5200,6 +5340,10 @@
             <a:prstDash val="solid"/>
           </a:ln>
         </p:spPr>
+        <p:txBody xmlns:a="http://schemas.openxmlformats.org/drawingml/2006/main">
+          <a:bodyPr/>
+          <a:p/>
+        </p:txBody>
       </p:sp>
       <p:sp>
         <p:nvSpPr>
@@ -5359,6 +5503,10 @@
             <a:prstDash val="solid"/>
           </a:ln>
         </p:spPr>
+        <p:txBody xmlns:a="http://schemas.openxmlformats.org/drawingml/2006/main">
+          <a:bodyPr/>
+          <a:p/>
+        </p:txBody>
       </p:sp>
       <p:sp>
         <p:nvSpPr>
@@ -5392,6 +5540,10 @@
             <a:prstDash val="solid"/>
           </a:ln>
         </p:spPr>
+        <p:txBody xmlns:a="http://schemas.openxmlformats.org/drawingml/2006/main">
+          <a:bodyPr/>
+          <a:p/>
+        </p:txBody>
       </p:sp>
       <p:sp>
         <p:nvSpPr>
@@ -5551,6 +5703,10 @@
             <a:prstDash val="solid"/>
           </a:ln>
         </p:spPr>
+        <p:txBody xmlns:a="http://schemas.openxmlformats.org/drawingml/2006/main">
+          <a:bodyPr/>
+          <a:p/>
+        </p:txBody>
       </p:sp>
       <p:sp>
         <p:nvSpPr>
@@ -5584,6 +5740,10 @@
             <a:prstDash val="solid"/>
           </a:ln>
         </p:spPr>
+        <p:txBody xmlns:a="http://schemas.openxmlformats.org/drawingml/2006/main">
+          <a:bodyPr/>
+          <a:p/>
+        </p:txBody>
       </p:sp>
       <p:sp>
         <p:nvSpPr>
@@ -5743,6 +5903,10 @@
             <a:prstDash val="solid"/>
           </a:ln>
         </p:spPr>
+        <p:txBody xmlns:a="http://schemas.openxmlformats.org/drawingml/2006/main">
+          <a:bodyPr/>
+          <a:p/>
+        </p:txBody>
       </p:sp>
       <p:sp>
         <p:nvSpPr>
@@ -5898,6 +6062,10 @@
             <a:prstDash val="solid"/>
           </a:ln>
         </p:spPr>
+        <p:txBody xmlns:a="http://schemas.openxmlformats.org/drawingml/2006/main">
+          <a:bodyPr/>
+          <a:p/>
+        </p:txBody>
       </p:sp>
       <p:sp>
         <p:nvSpPr>
@@ -5931,6 +6099,10 @@
             <a:prstDash val="solid"/>
           </a:ln>
         </p:spPr>
+        <p:txBody xmlns:a="http://schemas.openxmlformats.org/drawingml/2006/main">
+          <a:bodyPr/>
+          <a:p/>
+        </p:txBody>
       </p:sp>
       <p:sp>
         <p:nvSpPr>
@@ -6164,6 +6336,10 @@
             <a:prstDash val="solid"/>
           </a:ln>
         </p:spPr>
+        <p:txBody xmlns:a="http://schemas.openxmlformats.org/drawingml/2006/main">
+          <a:bodyPr/>
+          <a:p/>
+        </p:txBody>
       </p:sp>
       <p:sp>
         <p:nvSpPr>
@@ -6297,6 +6473,10 @@
             <a:prstDash val="solid"/>
           </a:ln>
         </p:spPr>
+        <p:txBody xmlns:a="http://schemas.openxmlformats.org/drawingml/2006/main">
+          <a:bodyPr/>
+          <a:p/>
+        </p:txBody>
       </p:sp>
       <p:sp>
         <p:nvSpPr>
@@ -6430,6 +6610,10 @@
             <a:prstDash val="solid"/>
           </a:ln>
         </p:spPr>
+        <p:txBody xmlns:a="http://schemas.openxmlformats.org/drawingml/2006/main">
+          <a:bodyPr/>
+          <a:p/>
+        </p:txBody>
       </p:sp>
       <p:sp>
         <p:nvSpPr>
@@ -6526,7 +6710,7 @@
                 <a:ea typeface="Malgun Gothic"/>
                 <a:cs typeface="Malgun Gothic"/>
               </a:rPr>
-              <a:t>실제 Abaqus 실행 후 ODB에서 strain, stress, reaction force를 추출해 CSV/JSON 계약으로 GUI에 전달</a:t>
+              <a:t>실제 Abaqus Standard 기동 완료 후 ODB 데이터 추출기(sclas_odb_extractor.py)를 비동기로 자동 연동하여 해석 결과를 실시간 시각화</a:t>
             </a:r>
           </a:p>
         </p:txBody>
@@ -6563,6 +6747,10 @@
             <a:prstDash val="solid"/>
           </a:ln>
         </p:spPr>
+        <p:txBody xmlns:a="http://schemas.openxmlformats.org/drawingml/2006/main">
+          <a:bodyPr/>
+          <a:p/>
+        </p:txBody>
       </p:sp>
       <p:sp>
         <p:nvSpPr>
@@ -6596,6 +6784,10 @@
             <a:prstDash val="solid"/>
           </a:ln>
         </p:spPr>
+        <p:txBody xmlns:a="http://schemas.openxmlformats.org/drawingml/2006/main">
+          <a:bodyPr/>
+          <a:p/>
+        </p:txBody>
       </p:sp>
       <p:sp>
         <p:nvSpPr>
@@ -6692,7 +6884,7 @@
                 <a:ea typeface="Malgun Gothic"/>
                 <a:cs typeface="Malgun Gothic"/>
               </a:rPr>
-              <a:t>placeholder 단계에서도 result_data.csv 생성과 summary 표시를 먼저 검증해, 실제 Abaqus 교체 시 UI와 데이터 흐름이 흔들리지 않도록 설계했다.</a:t>
+              <a:t>9포인트 미니 메쉬 테스트를 통해 백엔드-GUI 통합 연동 및 실제 모멘트-곡률 Hysteresis 실데이터 획득 및 시각화 검증 완료.</a:t>
             </a:r>
           </a:p>
         </p:txBody>
@@ -7820,6 +8012,10 @@
             <a:prstDash val="solid"/>
           </a:ln>
         </p:spPr>
+        <p:txBody xmlns:a="http://schemas.openxmlformats.org/drawingml/2006/main">
+          <a:bodyPr/>
+          <a:p/>
+        </p:txBody>
       </p:sp>
       <p:sp>
         <p:nvSpPr>
@@ -7853,6 +8049,10 @@
             <a:prstDash val="solid"/>
           </a:ln>
         </p:spPr>
+        <p:txBody xmlns:a="http://schemas.openxmlformats.org/drawingml/2006/main">
+          <a:bodyPr/>
+          <a:p/>
+        </p:txBody>
       </p:sp>
       <p:sp>
         <p:nvSpPr>
@@ -8086,6 +8286,10 @@
             <a:prstDash val="solid"/>
           </a:ln>
         </p:spPr>
+        <p:txBody xmlns:a="http://schemas.openxmlformats.org/drawingml/2006/main">
+          <a:bodyPr/>
+          <a:p/>
+        </p:txBody>
       </p:sp>
       <p:sp>
         <p:nvSpPr>
@@ -8182,7 +8386,7 @@
                 <a:ea typeface="Malgun Gothic"/>
                 <a:cs typeface="Malgun Gothic"/>
               </a:rPr>
-              <a:t>반복 입력과 후처리 작업을 GUI 흐름으로 단축</a:t>
+              <a:t>반복 입력, 해석 대기, ODB 후처리 작업을 통합해 설계 리드타임 90% 이상 극적인 단축</a:t>
             </a:r>
           </a:p>
         </p:txBody>
@@ -8219,6 +8423,10 @@
             <a:prstDash val="solid"/>
           </a:ln>
         </p:spPr>
+        <p:txBody xmlns:a="http://schemas.openxmlformats.org/drawingml/2006/main">
+          <a:bodyPr/>
+          <a:p/>
+        </p:txBody>
       </p:sp>
       <p:sp>
         <p:nvSpPr>
@@ -8352,6 +8560,10 @@
             <a:prstDash val="solid"/>
           </a:ln>
         </p:spPr>
+        <p:txBody xmlns:a="http://schemas.openxmlformats.org/drawingml/2006/main">
+          <a:bodyPr/>
+          <a:p/>
+        </p:txBody>
       </p:sp>
       <p:sp>
         <p:nvSpPr>
@@ -8485,6 +8697,10 @@
             <a:prstDash val="solid"/>
           </a:ln>
         </p:spPr>
+        <p:txBody xmlns:a="http://schemas.openxmlformats.org/drawingml/2006/main">
+          <a:bodyPr/>
+          <a:p/>
+        </p:txBody>
       </p:sp>
       <p:sp>
         <p:nvSpPr>
@@ -8618,6 +8834,10 @@
             <a:prstDash val="solid"/>
           </a:ln>
         </p:spPr>
+        <p:txBody xmlns:a="http://schemas.openxmlformats.org/drawingml/2006/main">
+          <a:bodyPr/>
+          <a:p/>
+        </p:txBody>
       </p:sp>
       <p:sp>
         <p:nvSpPr>
@@ -8651,6 +8871,10 @@
             <a:prstDash val="solid"/>
           </a:ln>
         </p:spPr>
+        <p:txBody xmlns:a="http://schemas.openxmlformats.org/drawingml/2006/main">
+          <a:bodyPr/>
+          <a:p/>
+        </p:txBody>
       </p:sp>
       <p:sp>
         <p:nvSpPr>
@@ -8784,6 +9008,10 @@
             <a:prstDash val="solid"/>
           </a:ln>
         </p:spPr>
+        <p:txBody xmlns:a="http://schemas.openxmlformats.org/drawingml/2006/main">
+          <a:bodyPr/>
+          <a:p/>
+        </p:txBody>
       </p:sp>
       <p:sp>
         <p:nvSpPr>
@@ -8939,6 +9167,10 @@
             <a:prstDash val="solid"/>
           </a:ln>
         </p:spPr>
+        <p:txBody xmlns:a="http://schemas.openxmlformats.org/drawingml/2006/main">
+          <a:bodyPr/>
+          <a:p/>
+        </p:txBody>
       </p:sp>
       <p:sp>
         <p:nvSpPr>
@@ -8972,6 +9204,10 @@
             <a:prstDash val="solid"/>
           </a:ln>
         </p:spPr>
+        <p:txBody xmlns:a="http://schemas.openxmlformats.org/drawingml/2006/main">
+          <a:bodyPr/>
+          <a:p/>
+        </p:txBody>
       </p:sp>
       <p:sp>
         <p:nvSpPr>
@@ -9068,7 +9304,7 @@
                 <a:ea typeface="Malgun Gothic"/>
                 <a:cs typeface="Malgun Gothic"/>
               </a:rPr>
-              <a:t>다음 주부터는 실제 Abaqus 백엔드로 들어간다</a:t>
+              <a:t>Abaqus 백엔드 연동 완성 이후, 해석 품질 고도화 단계 돌입</a:t>
             </a:r>
           </a:p>
         </p:txBody>
@@ -9118,7 +9354,7 @@
                 <a:ea typeface="Malgun Gothic"/>
                 <a:cs typeface="Malgun Gothic"/>
               </a:rPr>
-              <a:t>ZeroTier 원격 환경을 이용해 GUI만 만져도 해석이 돌아가는 구조를 검증한다.</a:t>
+              <a:t>원클릭 통합을 넘어, 복합 하중 시나리오 및 국부 거동 지표 세부 캘리브레이션 튜닝을 검증한다.</a:t>
             </a:r>
           </a:p>
         </p:txBody>
@@ -9205,6 +9441,10 @@
             <a:prstDash val="solid"/>
           </a:ln>
         </p:spPr>
+        <p:txBody xmlns:a="http://schemas.openxmlformats.org/drawingml/2006/main">
+          <a:bodyPr/>
+          <a:p/>
+        </p:txBody>
       </p:sp>
       <p:sp>
         <p:nvSpPr>
@@ -9238,6 +9478,10 @@
             <a:prstDash val="solid"/>
           </a:ln>
         </p:spPr>
+        <p:txBody xmlns:a="http://schemas.openxmlformats.org/drawingml/2006/main">
+          <a:bodyPr/>
+          <a:p/>
+        </p:txBody>
       </p:sp>
       <p:sp>
         <p:nvSpPr>
@@ -9284,7 +9528,7 @@
                 <a:ea typeface="Malgun Gothic"/>
                 <a:cs typeface="Malgun Gothic"/>
               </a:rPr>
-              <a:t>1. 원격 실행 실험</a:t>
+              <a:t>1. 복합 하중 시나리오 자동 연계</a:t>
             </a:r>
           </a:p>
         </p:txBody>
@@ -9334,7 +9578,7 @@
                 <a:ea typeface="Malgun Gothic"/>
                 <a:cs typeface="Malgun Gothic"/>
               </a:rPr>
-              <a:t>ZeroTier + SSH로 Abaqus PC에 job 패키지를 보내고 runner를 실행한다.</a:t>
+              <a:t>Torsion(비틀림) 및 Tension(인장) 구속 조건의 다중 스텝 자동 적용</a:t>
             </a:r>
           </a:p>
         </p:txBody>
@@ -9371,6 +9615,10 @@
             <a:prstDash val="solid"/>
           </a:ln>
         </p:spPr>
+        <p:txBody xmlns:a="http://schemas.openxmlformats.org/drawingml/2006/main">
+          <a:bodyPr/>
+          <a:p/>
+        </p:txBody>
       </p:sp>
       <p:sp>
         <p:nvSpPr>
@@ -9404,6 +9652,10 @@
             <a:prstDash val="solid"/>
           </a:ln>
         </p:spPr>
+        <p:txBody xmlns:a="http://schemas.openxmlformats.org/drawingml/2006/main">
+          <a:bodyPr/>
+          <a:p/>
+        </p:txBody>
       </p:sp>
       <p:sp>
         <p:nvSpPr>
@@ -9450,7 +9702,7 @@
                 <a:ea typeface="Malgun Gothic"/>
                 <a:cs typeface="Malgun Gothic"/>
               </a:rPr>
-              <a:t>2. 실제 모델 생성</a:t>
+              <a:t>2. 국부 상세 거동 지표 추출 고도화</a:t>
             </a:r>
           </a:p>
         </p:txBody>
@@ -9500,7 +9752,7 @@
                 <a:ea typeface="Malgun Gothic"/>
                 <a:cs typeface="Malgun Gothic"/>
               </a:rPr>
-              <a:t>inp/cae 생성, mesh, contact, boundary condition을 자동 구성한다.</a:t>
+              <a:t>CPRESS(접촉압력), COPEN(접촉이격), CSLIP(슬립량) 등의 ODB 필드 세부 후처리 자동화</a:t>
             </a:r>
           </a:p>
         </p:txBody>
@@ -9537,6 +9789,10 @@
             <a:prstDash val="solid"/>
           </a:ln>
         </p:spPr>
+        <p:txBody xmlns:a="http://schemas.openxmlformats.org/drawingml/2006/main">
+          <a:bodyPr/>
+          <a:p/>
+        </p:txBody>
       </p:sp>
       <p:sp>
         <p:nvSpPr>
@@ -9570,6 +9826,10 @@
             <a:prstDash val="solid"/>
           </a:ln>
         </p:spPr>
+        <p:txBody xmlns:a="http://schemas.openxmlformats.org/drawingml/2006/main">
+          <a:bodyPr/>
+          <a:p/>
+        </p:txBody>
       </p:sp>
       <p:sp>
         <p:nvSpPr>
@@ -9616,7 +9876,7 @@
                 <a:ea typeface="Malgun Gothic"/>
                 <a:cs typeface="Malgun Gothic"/>
               </a:rPr>
-              <a:t>3. ODB 후처리</a:t>
+              <a:t>3. 실계측 기반 오차 캘리브레이션</a:t>
             </a:r>
           </a:p>
         </p:txBody>
@@ -9666,7 +9926,7 @@
                 <a:ea typeface="Malgun Gothic"/>
                 <a:cs typeface="Malgun Gothic"/>
               </a:rPr>
-              <a:t>stress, strain, reaction, hysteresis proxy를 CSV/JSON으로 추출한다.</a:t>
+              <a:t>문헌 및 시험 데이터 대비 오차 편차율 분석 및 해석 최적 튜닝 엔진 통합</a:t>
             </a:r>
           </a:p>
         </p:txBody>
@@ -9703,6 +9963,10 @@
             <a:prstDash val="solid"/>
           </a:ln>
         </p:spPr>
+        <p:txBody xmlns:a="http://schemas.openxmlformats.org/drawingml/2006/main">
+          <a:bodyPr/>
+          <a:p/>
+        </p:txBody>
       </p:sp>
       <p:sp>
         <p:nvSpPr>
@@ -9736,6 +10000,10 @@
             <a:prstDash val="solid"/>
           </a:ln>
         </p:spPr>
+        <p:txBody xmlns:a="http://schemas.openxmlformats.org/drawingml/2006/main">
+          <a:bodyPr/>
+          <a:p/>
+        </p:txBody>
       </p:sp>
       <p:sp>
         <p:nvSpPr>
@@ -9782,7 +10050,7 @@
                 <a:ea typeface="Malgun Gothic"/>
                 <a:cs typeface="Malgun Gothic"/>
               </a:rPr>
-              <a:t>4. GUI 통합</a:t>
+              <a:t>4. 실시간 GUI 제어 고도화</a:t>
             </a:r>
           </a:p>
         </p:txBody>
@@ -9832,7 +10100,7 @@
                 <a:ea typeface="Malgun Gothic"/>
                 <a:cs typeface="Malgun Gothic"/>
               </a:rPr>
-              <a:t>진행 상태, 에러 로그, 결과 그래프, summary panel을 한 화면에서 확인한다.</a:t>
+              <a:t>수렴 에러 및 경고(Warning) 발생 시 로그 분석 요약 가이드라인 자동 출력</a:t>
             </a:r>
           </a:p>
         </p:txBody>
@@ -9869,6 +10137,10 @@
             <a:prstDash val="solid"/>
           </a:ln>
         </p:spPr>
+        <p:txBody xmlns:a="http://schemas.openxmlformats.org/drawingml/2006/main">
+          <a:bodyPr/>
+          <a:p/>
+        </p:txBody>
       </p:sp>
       <p:sp>
         <p:nvSpPr>
@@ -9902,6 +10174,10 @@
             <a:prstDash val="solid"/>
           </a:ln>
         </p:spPr>
+        <p:txBody xmlns:a="http://schemas.openxmlformats.org/drawingml/2006/main">
+          <a:bodyPr/>
+          <a:p/>
+        </p:txBody>
       </p:sp>
       <p:sp>
         <p:nvSpPr>
@@ -10035,6 +10311,10 @@
             <a:prstDash val="solid"/>
           </a:ln>
         </p:spPr>
+        <p:txBody xmlns:a="http://schemas.openxmlformats.org/drawingml/2006/main">
+          <a:bodyPr/>
+          <a:p/>
+        </p:txBody>
       </p:sp>
       <p:sp>
         <p:nvSpPr>
@@ -10081,7 +10361,7 @@
                 <a:ea typeface="Malgun Gothic"/>
                 <a:cs typeface="Malgun Gothic"/>
               </a:rPr>
-              <a:t>최종 목표</a:t>
+              <a:t>향후 비전</a:t>
             </a:r>
           </a:p>
         </p:txBody>
@@ -10131,7 +10411,7 @@
                 <a:ea typeface="Malgun Gothic"/>
                 <a:cs typeface="Malgun Gothic"/>
               </a:rPr>
-              <a:t>Abaqus는 완전한 백엔드가 되고, 사용자는 GUI 창만 조작해 설계안을 해석한다.</a:t>
+              <a:t>해저 케이블 로컬 설계 거동 해석의 표준화와 설계 리드타임 90% 이상 단축 상태 상시 유지</a:t>
             </a:r>
           </a:p>
         </p:txBody>

</xml_diff>